<commit_message>
added 2025 Python contest notes
</commit_message>
<xml_diff>
--- a/python/decaboard/mousePointExample/pointingToTheMouse.pptx
+++ b/python/decaboard/mousePointExample/pointingToTheMouse.pptx
@@ -139,6 +139,30 @@
 
 <file path=ppt/changesInfos/changesInfo1.xml><?xml version="1.0" encoding="utf-8"?>
 <pc:chgInfo xmlns:a="http://schemas.openxmlformats.org/drawingml/2006/main" xmlns:r="http://schemas.openxmlformats.org/officeDocument/2006/relationships" xmlns:ac="http://schemas.microsoft.com/office/drawing/2013/main/command" xmlns:pc="http://schemas.microsoft.com/office/powerpoint/2013/main/command">
+  <pc:docChgLst>
+    <pc:chgData name="Toby Donaldson" userId="2e6e5431-bb17-4c41-9985-d39c50d83c73" providerId="ADAL" clId="{F31BC264-820E-54C4-A6D1-F92AF9CC222E}"/>
+    <pc:docChg chg="custSel modSld">
+      <pc:chgData name="Toby Donaldson" userId="2e6e5431-bb17-4c41-9985-d39c50d83c73" providerId="ADAL" clId="{F31BC264-820E-54C4-A6D1-F92AF9CC222E}" dt="2025-12-04T17:53:42.207" v="0" actId="21"/>
+      <pc:docMkLst>
+        <pc:docMk/>
+      </pc:docMkLst>
+      <pc:sldChg chg="delSp mod">
+        <pc:chgData name="Toby Donaldson" userId="2e6e5431-bb17-4c41-9985-d39c50d83c73" providerId="ADAL" clId="{F31BC264-820E-54C4-A6D1-F92AF9CC222E}" dt="2025-12-04T17:53:42.207" v="0" actId="21"/>
+        <pc:sldMkLst>
+          <pc:docMk/>
+          <pc:sldMk cId="27877428" sldId="256"/>
+        </pc:sldMkLst>
+        <pc:spChg chg="del">
+          <ac:chgData name="Toby Donaldson" userId="2e6e5431-bb17-4c41-9985-d39c50d83c73" providerId="ADAL" clId="{F31BC264-820E-54C4-A6D1-F92AF9CC222E}" dt="2025-12-04T17:53:42.207" v="0" actId="21"/>
+          <ac:spMkLst>
+            <pc:docMk/>
+            <pc:sldMk cId="27877428" sldId="256"/>
+            <ac:spMk id="5" creationId="{15F70858-1AFE-26EC-3911-D2568A3900CA}"/>
+          </ac:spMkLst>
+        </pc:spChg>
+      </pc:sldChg>
+    </pc:docChg>
+  </pc:docChgLst>
   <pc:docChgLst>
     <pc:chgData name="Toby Donaldson" userId="2e6e5431-bb17-4c41-9985-d39c50d83c73" providerId="ADAL" clId="{7F9681A8-EEE2-56F4-9B39-ECCBEE0471AC}"/>
     <pc:docChg chg="undo custSel addSld delSld modSld sldOrd">
@@ -1609,7 +1633,7 @@
           <a:p>
             <a:fld id="{AF25B698-1438-5A4E-A02E-B7A020DE835D}" type="datetimeFigureOut">
               <a:rPr lang="en-US" smtClean="0"/>
-              <a:t>12/3/25</a:t>
+              <a:t>12/4/25</a:t>
             </a:fld>
             <a:endParaRPr lang="en-US"/>
           </a:p>
@@ -2023,7 +2047,7 @@
           <a:p>
             <a:fld id="{74BE2683-176A-8347-B828-AB3139E6C601}" type="datetimeFigureOut">
               <a:rPr lang="en-US" smtClean="0"/>
-              <a:t>12/3/25</a:t>
+              <a:t>12/4/25</a:t>
             </a:fld>
             <a:endParaRPr lang="en-US"/>
           </a:p>
@@ -2221,7 +2245,7 @@
           <a:p>
             <a:fld id="{74BE2683-176A-8347-B828-AB3139E6C601}" type="datetimeFigureOut">
               <a:rPr lang="en-US" smtClean="0"/>
-              <a:t>12/3/25</a:t>
+              <a:t>12/4/25</a:t>
             </a:fld>
             <a:endParaRPr lang="en-US"/>
           </a:p>
@@ -2429,7 +2453,7 @@
           <a:p>
             <a:fld id="{74BE2683-176A-8347-B828-AB3139E6C601}" type="datetimeFigureOut">
               <a:rPr lang="en-US" smtClean="0"/>
-              <a:t>12/3/25</a:t>
+              <a:t>12/4/25</a:t>
             </a:fld>
             <a:endParaRPr lang="en-US"/>
           </a:p>
@@ -2627,7 +2651,7 @@
           <a:p>
             <a:fld id="{74BE2683-176A-8347-B828-AB3139E6C601}" type="datetimeFigureOut">
               <a:rPr lang="en-US" smtClean="0"/>
-              <a:t>12/3/25</a:t>
+              <a:t>12/4/25</a:t>
             </a:fld>
             <a:endParaRPr lang="en-US"/>
           </a:p>
@@ -2902,7 +2926,7 @@
           <a:p>
             <a:fld id="{74BE2683-176A-8347-B828-AB3139E6C601}" type="datetimeFigureOut">
               <a:rPr lang="en-US" smtClean="0"/>
-              <a:t>12/3/25</a:t>
+              <a:t>12/4/25</a:t>
             </a:fld>
             <a:endParaRPr lang="en-US"/>
           </a:p>
@@ -3167,7 +3191,7 @@
           <a:p>
             <a:fld id="{74BE2683-176A-8347-B828-AB3139E6C601}" type="datetimeFigureOut">
               <a:rPr lang="en-US" smtClean="0"/>
-              <a:t>12/3/25</a:t>
+              <a:t>12/4/25</a:t>
             </a:fld>
             <a:endParaRPr lang="en-US"/>
           </a:p>
@@ -3579,7 +3603,7 @@
           <a:p>
             <a:fld id="{74BE2683-176A-8347-B828-AB3139E6C601}" type="datetimeFigureOut">
               <a:rPr lang="en-US" smtClean="0"/>
-              <a:t>12/3/25</a:t>
+              <a:t>12/4/25</a:t>
             </a:fld>
             <a:endParaRPr lang="en-US"/>
           </a:p>
@@ -3720,7 +3744,7 @@
           <a:p>
             <a:fld id="{74BE2683-176A-8347-B828-AB3139E6C601}" type="datetimeFigureOut">
               <a:rPr lang="en-US" smtClean="0"/>
-              <a:t>12/3/25</a:t>
+              <a:t>12/4/25</a:t>
             </a:fld>
             <a:endParaRPr lang="en-US"/>
           </a:p>
@@ -3833,7 +3857,7 @@
           <a:p>
             <a:fld id="{74BE2683-176A-8347-B828-AB3139E6C601}" type="datetimeFigureOut">
               <a:rPr lang="en-US" smtClean="0"/>
-              <a:t>12/3/25</a:t>
+              <a:t>12/4/25</a:t>
             </a:fld>
             <a:endParaRPr lang="en-US"/>
           </a:p>
@@ -4144,7 +4168,7 @@
           <a:p>
             <a:fld id="{74BE2683-176A-8347-B828-AB3139E6C601}" type="datetimeFigureOut">
               <a:rPr lang="en-US" smtClean="0"/>
-              <a:t>12/3/25</a:t>
+              <a:t>12/4/25</a:t>
             </a:fld>
             <a:endParaRPr lang="en-US"/>
           </a:p>
@@ -4432,7 +4456,7 @@
           <a:p>
             <a:fld id="{74BE2683-176A-8347-B828-AB3139E6C601}" type="datetimeFigureOut">
               <a:rPr lang="en-US" smtClean="0"/>
-              <a:t>12/3/25</a:t>
+              <a:t>12/4/25</a:t>
             </a:fld>
             <a:endParaRPr lang="en-US"/>
           </a:p>
@@ -4673,7 +4697,7 @@
           <a:p>
             <a:fld id="{74BE2683-176A-8347-B828-AB3139E6C601}" type="datetimeFigureOut">
               <a:rPr lang="en-US" smtClean="0"/>
-              <a:t>12/3/25</a:t>
+              <a:t>12/4/25</a:t>
             </a:fld>
             <a:endParaRPr lang="en-US"/>
           </a:p>
@@ -5118,31 +5142,6 @@
           </a:p>
         </p:txBody>
       </p:sp>
-      <p:sp>
-        <p:nvSpPr>
-          <p:cNvPr id="5" name="Subtitle 4">
-            <a:extLst>
-              <a:ext uri="{FF2B5EF4-FFF2-40B4-BE49-F238E27FC236}">
-                <a16:creationId xmlns:a16="http://schemas.microsoft.com/office/drawing/2014/main" id="{15F70858-1AFE-26EC-3911-D2568A3900CA}"/>
-              </a:ext>
-            </a:extLst>
-          </p:cNvPr>
-          <p:cNvSpPr>
-            <a:spLocks noGrp="1"/>
-          </p:cNvSpPr>
-          <p:nvPr>
-            <p:ph type="subTitle" idx="1"/>
-          </p:nvPr>
-        </p:nvSpPr>
-        <p:spPr/>
-        <p:txBody>
-          <a:bodyPr/>
-          <a:lstStyle/>
-          <a:p>
-            <a:endParaRPr lang="en-US"/>
-          </a:p>
-        </p:txBody>
-      </p:sp>
     </p:spTree>
     <p:extLst>
       <p:ext uri="{BB962C8B-B14F-4D97-AF65-F5344CB8AC3E}">
@@ -6275,8 +6274,8 @@
           </a:p>
         </p:txBody>
       </p:sp>
-      <mc:AlternateContent xmlns:mc="http://schemas.openxmlformats.org/markup-compatibility/2006">
-        <mc:Choice xmlns:a14="http://schemas.microsoft.com/office/drawing/2010/main" Requires="a14">
+      <mc:AlternateContent xmlns:mc="http://schemas.openxmlformats.org/markup-compatibility/2006" xmlns:a14="http://schemas.microsoft.com/office/drawing/2010/main">
+        <mc:Choice Requires="a14">
           <p:sp>
             <p:nvSpPr>
               <p:cNvPr id="5" name="TextBox 4">
@@ -6458,7 +6457,7 @@
             </p:txBody>
           </p:sp>
         </mc:Choice>
-        <mc:Fallback>
+        <mc:Fallback xmlns="">
           <p:sp>
             <p:nvSpPr>
               <p:cNvPr id="5" name="TextBox 4">
@@ -7917,8 +7916,8 @@
           </a:p>
         </p:txBody>
       </p:sp>
-      <mc:AlternateContent xmlns:mc="http://schemas.openxmlformats.org/markup-compatibility/2006">
-        <mc:Choice xmlns:a14="http://schemas.microsoft.com/office/drawing/2010/main" Requires="a14">
+      <mc:AlternateContent xmlns:mc="http://schemas.openxmlformats.org/markup-compatibility/2006" xmlns:a14="http://schemas.microsoft.com/office/drawing/2010/main">
+        <mc:Choice Requires="a14">
           <p:sp>
             <p:nvSpPr>
               <p:cNvPr id="5" name="TextBox 4">
@@ -8100,7 +8099,7 @@
             </p:txBody>
           </p:sp>
         </mc:Choice>
-        <mc:Fallback>
+        <mc:Fallback xmlns="">
           <p:sp>
             <p:nvSpPr>
               <p:cNvPr id="5" name="TextBox 4">
@@ -9655,8 +9654,8 @@
           </a:p>
         </p:txBody>
       </p:sp>
-      <mc:AlternateContent xmlns:mc="http://schemas.openxmlformats.org/markup-compatibility/2006">
-        <mc:Choice xmlns:a14="http://schemas.microsoft.com/office/drawing/2010/main" Requires="a14">
+      <mc:AlternateContent xmlns:mc="http://schemas.openxmlformats.org/markup-compatibility/2006" xmlns:a14="http://schemas.microsoft.com/office/drawing/2010/main">
+        <mc:Choice Requires="a14">
           <p:sp>
             <p:nvSpPr>
               <p:cNvPr id="5" name="TextBox 4">
@@ -9838,7 +9837,7 @@
             </p:txBody>
           </p:sp>
         </mc:Choice>
-        <mc:Fallback>
+        <mc:Fallback xmlns="">
           <p:sp>
             <p:nvSpPr>
               <p:cNvPr id="5" name="TextBox 4">

</xml_diff>